<commit_message>
Actualizar entregables del Sprint 2: responsables planificados y decisiones
- Responsables planificados por módulo en backlog y plan de pruebas.
- RR-09: despliegue local/pruebas para el MVP, nube en fase posterior.
- UC-13 (cliente internacional) definido como fuera del MVP.
- Notas de la demo y estado actual alineados con el prototipo de frontend.
- Se mantienen como [COMPLETAR] la autoría del Sprint 1, las contribuciones
  individuales y los resultados de las pruebas.
</commit_message>
<xml_diff>
--- a/docs/sprint2/CoffeeExport_Manager_Sprint2.pptx
+++ b/docs/sprint2/CoffeeExport_Manager_Sprint2.pptx
@@ -586,7 +586,7 @@
           <a:lstStyle/>
           <a:p>
             <a:r>
-              <a:t>Diapositiva de Juan Jurado. Módulos propuestos: Clientes y Pagos. Esta asignación es una propuesta tentativa basada en el reparto del backlog; el integrante debe completar los marcadores [COMPLETAR] con su trabajo real (commits, pull requests, tareas de Jira y aportes de documentación o pruebas) y ajustar el módulo si difiere. Tiempo: 1 minuto.</a:t>
+              <a:t>Diapositiva de Juan Jurado. Módulos propuestos: Clientes y Pagos. Esta es la responsabilidad planificada por módulo; el integrante debe completar los marcadores [COMPLETAR] con su trabajo real (commits, pull requests, tareas de Jira y aportes de documentación o pruebas) y ajustar el módulo si difiere. Tiempo: 1 minuto.</a:t>
             </a:r>
           </a:p>
         </p:txBody>
@@ -656,7 +656,7 @@
           <a:lstStyle/>
           <a:p>
             <a:r>
-              <a:t>Diapositiva de Nicoll López. Módulos propuestos: Productos y Documentación. Esta asignación es una propuesta tentativa basada en el reparto del backlog; el integrante debe completar los marcadores [COMPLETAR] con su trabajo real (commits, pull requests, tareas de Jira y aportes de documentación o pruebas) y ajustar el módulo si difiere. Tiempo: 1 minuto.</a:t>
+              <a:t>Diapositiva de Nicoll López. Módulos propuestos: Productos y Documentación. Esta es la responsabilidad planificada por módulo; el integrante debe completar los marcadores [COMPLETAR] con su trabajo real (commits, pull requests, tareas de Jira y aportes de documentación o pruebas) y ajustar el módulo si difiere. Tiempo: 1 minuto.</a:t>
             </a:r>
           </a:p>
         </p:txBody>
@@ -726,7 +726,7 @@
           <a:lstStyle/>
           <a:p>
             <a:r>
-              <a:t>Diapositiva de Alexander Rodríguez. Módulos propuestos: Inventario y Exportaciones. Esta asignación es una propuesta tentativa basada en el reparto del backlog; el integrante debe completar los marcadores [COMPLETAR] con su trabajo real (commits, pull requests, tareas de Jira y aportes de documentación o pruebas) y ajustar el módulo si difiere. Tiempo: 1 minuto.</a:t>
+              <a:t>Diapositiva de Alexander Rodríguez. Módulos propuestos: Inventario y Exportaciones. Esta es la responsabilidad planificada por módulo; el integrante debe completar los marcadores [COMPLETAR] con su trabajo real (commits, pull requests, tareas de Jira y aportes de documentación o pruebas) y ajustar el módulo si difiere. Tiempo: 1 minuto.</a:t>
             </a:r>
           </a:p>
         </p:txBody>
@@ -796,7 +796,7 @@
           <a:lstStyle/>
           <a:p>
             <a:r>
-              <a:t>Diapositiva de Mario Zambrano. Módulos propuestos: Reportes y pruebas de seguridad transversales. Esta asignación es una propuesta tentativa basada en el reparto del backlog; el integrante debe completar los marcadores [COMPLETAR] con su trabajo real (commits, pull requests, tareas de Jira y aportes de documentación o pruebas) y ajustar el módulo si difiere. Tiempo: 1 minuto.</a:t>
+              <a:t>Diapositiva de Mario Zambrano. Módulos propuestos: Reportes y pruebas de seguridad transversales. Esta es la responsabilidad planificada por módulo; el integrante debe completar los marcadores [COMPLETAR] con su trabajo real (commits, pull requests, tareas de Jira y aportes de documentación o pruebas) y ajustar el módulo si difiere. Tiempo: 1 minuto.</a:t>
             </a:r>
           </a:p>
         </p:txBody>
@@ -866,7 +866,7 @@
           <a:lstStyle/>
           <a:p>
             <a:r>
-              <a:t>GUION DE LA DEMO (aprox. 2 minutos). Aclarar antes de iniciar qué pantallas son funcionales y cuáles son mockups [COMPLETAR].</a:t>
+              <a:t>GUION DE LA DEMO (aprox. 2 minutos). Aclarar al inicio que se muestra el prototipo de frontend (carpeta frontend/ del repositorio): las 9 pantallas funcionan con datos de demostración guardados en el navegador; el backend Spring Boot y MySQL aún no está conectado. Cuentas de demo: botones en la pantalla de Login.</a:t>
             </a:r>
           </a:p>
           <a:p>
@@ -876,7 +876,7 @@
           </a:p>
           <a:p>
             <a:r>
-              <a:t>2) Dashboard: mostrar los KPIs (total de exportaciones, clientes activos, inventario en kg, ventas del mes en USD), la gráfica de exportaciones por país, productos más vendidos y las últimas exportaciones. Indicar si los datos son reales o de ejemplo [COMPLETAR].</a:t>
+              <a:t>2) Dashboard: mostrar los KPIs (total de exportaciones, clientes activos, inventario en kg, ventas del mes en USD), la gráfica de exportaciones por país, productos más vendidos y las últimas exportaciones. Los datos son de demostración.</a:t>
             </a:r>
           </a:p>
           <a:p>
@@ -886,7 +886,7 @@
           </a:p>
           <a:p>
             <a:r>
-              <a:t>4) Nueva Exportación: recorrer el asistente de 4 pasos: información básica; cliente y destino con puerto de salida, puerto de llegada y fecha de envío; productos y cantidades; documentos. Aclarar que este módulo se implementa en el Sprint 3 [COMPLETAR si es solo mockup].</a:t>
+              <a:t>4) Nueva Exportación: recorrer el asistente de 4 pasos: información básica; cliente y destino con puerto de salida, puerto de llegada y fecha de envío; productos y cantidades; documentos. En el prototipo el asistente ya funciona completo (valida stock y descuenta inventario); la persistencia real llegará con el backend en el Sprint 3.</a:t>
             </a:r>
           </a:p>
           <a:p>
@@ -1526,7 +1526,7 @@
           <a:lstStyle/>
           <a:p>
             <a:r>
-              <a:t>Diapositiva de Brayan Guerrero. Módulos propuestos: Usuarios / Autenticación y Dashboard. Esta asignación es una propuesta tentativa basada en el reparto del backlog; el integrante debe completar los marcadores [COMPLETAR] con su trabajo real (commits, pull requests, tareas de Jira y aportes de documentación o pruebas) y ajustar el módulo si difiere. Tiempo: 1 minuto.</a:t>
+              <a:t>Diapositiva de Brayan Guerrero. Módulos propuestos: Usuarios / Autenticación y Dashboard. Esta es la responsabilidad planificada por módulo; el integrante debe completar los marcadores [COMPLETAR] con su trabajo real (commits, pull requests, tareas de Jira y aportes de documentación o pruebas) y ajustar el módulo si difiere. Tiempo: 1 minuto.</a:t>
             </a:r>
           </a:p>
         </p:txBody>
@@ -4973,7 +4973,7 @@
                 </a:solidFill>
                 <a:latin typeface="Calibri"/>
               </a:rPr>
-              <a:t>Trabajo individual y contribuciones · asignación propuesta, por validar</a:t>
+              <a:t>Responsabilidades planificadas y contribuciones</a:t>
             </a:r>
           </a:p>
         </p:txBody>
@@ -5124,7 +5124,7 @@
                 </a:solidFill>
                 <a:latin typeface="Calibri"/>
               </a:rPr>
-              <a:t>Módulos / áreas (propuesta)</a:t>
+              <a:t>Módulos / áreas planificados</a:t>
             </a:r>
           </a:p>
         </p:txBody>
@@ -5323,7 +5323,7 @@
                 </a:solidFill>
                 <a:latin typeface="Calibri"/>
               </a:rPr>
-              <a:t>Casos asignados (propuesta): </a:t>
+              <a:t>Casos asignados: </a:t>
             </a:r>
             <a:r>
               <a:rPr sz="1300">
@@ -5848,7 +5848,7 @@
                 </a:solidFill>
                 <a:latin typeface="Calibri"/>
               </a:rPr>
-              <a:t>Trabajo individual y contribuciones · asignación propuesta, por validar</a:t>
+              <a:t>Responsabilidades planificadas y contribuciones</a:t>
             </a:r>
           </a:p>
         </p:txBody>
@@ -5999,7 +5999,7 @@
                 </a:solidFill>
                 <a:latin typeface="Calibri"/>
               </a:rPr>
-              <a:t>Módulos / áreas (propuesta)</a:t>
+              <a:t>Módulos / áreas planificados</a:t>
             </a:r>
           </a:p>
         </p:txBody>
@@ -6198,7 +6198,7 @@
                 </a:solidFill>
                 <a:latin typeface="Calibri"/>
               </a:rPr>
-              <a:t>Casos asignados (propuesta): </a:t>
+              <a:t>Casos asignados: </a:t>
             </a:r>
             <a:r>
               <a:rPr sz="1300">
@@ -6723,7 +6723,7 @@
                 </a:solidFill>
                 <a:latin typeface="Calibri"/>
               </a:rPr>
-              <a:t>Trabajo individual y contribuciones · asignación propuesta, por validar</a:t>
+              <a:t>Responsabilidades planificadas y contribuciones</a:t>
             </a:r>
           </a:p>
         </p:txBody>
@@ -6874,7 +6874,7 @@
                 </a:solidFill>
                 <a:latin typeface="Calibri"/>
               </a:rPr>
-              <a:t>Módulos / áreas (propuesta)</a:t>
+              <a:t>Módulos / áreas planificados</a:t>
             </a:r>
           </a:p>
         </p:txBody>
@@ -7073,7 +7073,7 @@
                 </a:solidFill>
                 <a:latin typeface="Calibri"/>
               </a:rPr>
-              <a:t>Casos asignados (propuesta): </a:t>
+              <a:t>Casos asignados: </a:t>
             </a:r>
             <a:r>
               <a:rPr sz="1300">
@@ -7598,7 +7598,7 @@
                 </a:solidFill>
                 <a:latin typeface="Calibri"/>
               </a:rPr>
-              <a:t>Trabajo individual y contribuciones · asignación propuesta, por validar</a:t>
+              <a:t>Responsabilidades planificadas y contribuciones</a:t>
             </a:r>
           </a:p>
         </p:txBody>
@@ -7749,7 +7749,7 @@
                 </a:solidFill>
                 <a:latin typeface="Calibri"/>
               </a:rPr>
-              <a:t>Módulos / áreas (propuesta)</a:t>
+              <a:t>Módulos / áreas planificados</a:t>
             </a:r>
           </a:p>
         </p:txBody>
@@ -7948,7 +7948,7 @@
                 </a:solidFill>
                 <a:latin typeface="Calibri"/>
               </a:rPr>
-              <a:t>Casos asignados (propuesta): </a:t>
+              <a:t>Casos asignados: </a:t>
             </a:r>
             <a:r>
               <a:rPr sz="1300">
@@ -10916,7 +10916,7 @@
                 </a:solidFill>
                 <a:latin typeface="Calibri"/>
               </a:rPr>
-              <a:t>Mockups: Login, Dashboard, Nueva Exportación, Reportes</a:t>
+              <a:t>Prototipo de frontend con las 9 pantallas</a:t>
             </a:r>
           </a:p>
           <a:p>
@@ -18545,7 +18545,7 @@
                 </a:solidFill>
                 <a:latin typeface="Calibri"/>
               </a:rPr>
-              <a:t>Trabajo individual y contribuciones · asignación propuesta, por validar</a:t>
+              <a:t>Responsabilidades planificadas y contribuciones</a:t>
             </a:r>
           </a:p>
         </p:txBody>
@@ -18696,7 +18696,7 @@
                 </a:solidFill>
                 <a:latin typeface="Calibri"/>
               </a:rPr>
-              <a:t>Módulos / áreas (propuesta)</a:t>
+              <a:t>Módulos / áreas planificados</a:t>
             </a:r>
           </a:p>
         </p:txBody>
@@ -18895,7 +18895,7 @@
                 </a:solidFill>
                 <a:latin typeface="Calibri"/>
               </a:rPr>
-              <a:t>Casos asignados (propuesta): </a:t>
+              <a:t>Casos asignados: </a:t>
             </a:r>
             <a:r>
               <a:rPr sz="1300">

</xml_diff>

<commit_message>
Presentación: compromisos del Sprint 3 y 4 por integrante
Las diapositivas individuales muestran las historias comprometidas por cada
integrante según el backlog. Se deja un único campo [COMPLETAR] por persona
para su aporte ya realizado (Jira/Git).
</commit_message>
<xml_diff>
--- a/docs/sprint2/CoffeeExport_Manager_Sprint2.pptx
+++ b/docs/sprint2/CoffeeExport_Manager_Sprint2.pptx
@@ -586,7 +586,7 @@
           <a:lstStyle/>
           <a:p>
             <a:r>
-              <a:t>Diapositiva de Juan Jurado. Módulos propuestos: Clientes y Pagos. Esta es la responsabilidad planificada por módulo; el integrante debe completar los marcadores [COMPLETAR] con su trabajo real (commits, pull requests, tareas de Jira y aportes de documentación o pruebas) y ajustar el módulo si difiere. Tiempo: 1 minuto.</a:t>
+              <a:t>Diapositiva de Juan Jurado. Módulos propuestos: Clientes y Pagos. Esta es la responsabilidad planificada por módulo; a la derecha están sus historias comprometidas para los Sprints 3 y 4 según el backlog. El integrante debe completar el único marcador [COMPLETAR] con su trabajo real (commits, pull requests, tareas de Jira y aportes de documentación o pruebas) y ajustar el módulo si difiere. Tiempo: 1 minuto.</a:t>
             </a:r>
           </a:p>
         </p:txBody>
@@ -656,7 +656,7 @@
           <a:lstStyle/>
           <a:p>
             <a:r>
-              <a:t>Diapositiva de Nicoll López. Módulos propuestos: Productos y Documentación. Esta es la responsabilidad planificada por módulo; el integrante debe completar los marcadores [COMPLETAR] con su trabajo real (commits, pull requests, tareas de Jira y aportes de documentación o pruebas) y ajustar el módulo si difiere. Tiempo: 1 minuto.</a:t>
+              <a:t>Diapositiva de Nicoll López. Módulos propuestos: Productos y Documentación. Esta es la responsabilidad planificada por módulo; a la derecha están sus historias comprometidas para los Sprints 3 y 4 según el backlog. El integrante debe completar el único marcador [COMPLETAR] con su trabajo real (commits, pull requests, tareas de Jira y aportes de documentación o pruebas) y ajustar el módulo si difiere. Tiempo: 1 minuto.</a:t>
             </a:r>
           </a:p>
         </p:txBody>
@@ -726,7 +726,7 @@
           <a:lstStyle/>
           <a:p>
             <a:r>
-              <a:t>Diapositiva de Alexander Rodríguez. Módulos propuestos: Inventario y Exportaciones. Esta es la responsabilidad planificada por módulo; el integrante debe completar los marcadores [COMPLETAR] con su trabajo real (commits, pull requests, tareas de Jira y aportes de documentación o pruebas) y ajustar el módulo si difiere. Tiempo: 1 minuto.</a:t>
+              <a:t>Diapositiva de Alexander Rodríguez. Módulos propuestos: Inventario y Exportaciones. Esta es la responsabilidad planificada por módulo; a la derecha están sus historias comprometidas para los Sprints 3 y 4 según el backlog. El integrante debe completar el único marcador [COMPLETAR] con su trabajo real (commits, pull requests, tareas de Jira y aportes de documentación o pruebas) y ajustar el módulo si difiere. Tiempo: 1 minuto.</a:t>
             </a:r>
           </a:p>
         </p:txBody>
@@ -796,7 +796,7 @@
           <a:lstStyle/>
           <a:p>
             <a:r>
-              <a:t>Diapositiva de Mario Zambrano. Módulos propuestos: Reportes y pruebas de seguridad transversales. Esta es la responsabilidad planificada por módulo; el integrante debe completar los marcadores [COMPLETAR] con su trabajo real (commits, pull requests, tareas de Jira y aportes de documentación o pruebas) y ajustar el módulo si difiere. Tiempo: 1 minuto.</a:t>
+              <a:t>Diapositiva de Mario Zambrano. Módulos propuestos: Reportes y pruebas de seguridad transversales. Esta es la responsabilidad planificada por módulo; a la derecha están sus historias comprometidas para los Sprints 3 y 4 según el backlog. El integrante debe completar el único marcador [COMPLETAR] con su trabajo real (commits, pull requests, tareas de Jira y aportes de documentación o pruebas) y ajustar el módulo si difiere. Tiempo: 1 minuto.</a:t>
             </a:r>
           </a:p>
         </p:txBody>
@@ -1526,7 +1526,7 @@
           <a:lstStyle/>
           <a:p>
             <a:r>
-              <a:t>Diapositiva de Brayan Guerrero. Módulos propuestos: Usuarios / Autenticación y Dashboard. Esta es la responsabilidad planificada por módulo; el integrante debe completar los marcadores [COMPLETAR] con su trabajo real (commits, pull requests, tareas de Jira y aportes de documentación o pruebas) y ajustar el módulo si difiere. Tiempo: 1 minuto.</a:t>
+              <a:t>Diapositiva de Brayan Guerrero. Módulos propuestos: Usuarios / Autenticación y Dashboard. Esta es la responsabilidad planificada por módulo; a la derecha están sus historias comprometidas para los Sprints 3 y 4 según el backlog. El integrante debe completar el único marcador [COMPLETAR] con su trabajo real (commits, pull requests, tareas de Jira y aportes de documentación o pruebas) y ajustar el módulo si difiere. Tiempo: 1 minuto.</a:t>
             </a:r>
           </a:p>
         </p:txBody>
@@ -5481,7 +5481,7 @@
                 </a:solidFill>
                 <a:latin typeface="Calibri"/>
               </a:rPr>
-              <a:t>Contribuciones</a:t>
+              <a:t>Compromisos y contribuciones</a:t>
             </a:r>
           </a:p>
         </p:txBody>
@@ -5510,11 +5510,11 @@
           <a:p>
             <a:pPr>
               <a:spcAft>
-                <a:spcPts val="1200"/>
+                <a:spcPts val="1000"/>
               </a:spcAft>
             </a:pPr>
             <a:r>
-              <a:rPr sz="1000">
+              <a:rPr sz="900">
                 <a:solidFill>
                   <a:srgbClr val="66BB6A"/>
                 </a:solidFill>
@@ -5523,32 +5523,32 @@
               <a:t>● </a:t>
             </a:r>
             <a:r>
-              <a:rPr b="1" sz="1500">
+              <a:rPr b="1" sz="1400">
                 <a:solidFill>
                   <a:srgbClr val="F3E9E2"/>
                 </a:solidFill>
                 <a:latin typeface="Calibri"/>
               </a:rPr>
-              <a:t>Trabajo realizado: </a:t>
-            </a:r>
-            <a:r>
-              <a:rPr sz="1500">
+              <a:t>HU-07: </a:t>
+            </a:r>
+            <a:r>
+              <a:rPr sz="1400">
                 <a:solidFill>
                   <a:srgbClr val="BCAAA4"/>
                 </a:solidFill>
                 <a:latin typeface="Calibri"/>
               </a:rPr>
-              <a:t>[COMPLETAR]</a:t>
+              <a:t>Búsqueda de clientes · 3 pts · Sprint 3</a:t>
             </a:r>
           </a:p>
           <a:p>
             <a:pPr>
               <a:spcAft>
-                <a:spcPts val="1200"/>
+                <a:spcPts val="1000"/>
               </a:spcAft>
             </a:pPr>
             <a:r>
-              <a:rPr sz="1000">
+              <a:rPr sz="900">
                 <a:solidFill>
                   <a:srgbClr val="66BB6A"/>
                 </a:solidFill>
@@ -5557,32 +5557,32 @@
               <a:t>● </a:t>
             </a:r>
             <a:r>
-              <a:rPr b="1" sz="1500">
+              <a:rPr b="1" sz="1400">
                 <a:solidFill>
                   <a:srgbClr val="F3E9E2"/>
                 </a:solidFill>
                 <a:latin typeface="Calibri"/>
               </a:rPr>
-              <a:t>Commits, ramas y pull requests: </a:t>
-            </a:r>
-            <a:r>
-              <a:rPr sz="1500">
+              <a:t>HU-16: </a:t>
+            </a:r>
+            <a:r>
+              <a:rPr sz="1400">
                 <a:solidFill>
                   <a:srgbClr val="BCAAA4"/>
                 </a:solidFill>
                 <a:latin typeface="Calibri"/>
               </a:rPr>
-              <a:t>[COMPLETAR]</a:t>
+              <a:t>Registrar pago internacional · 5 pts · Sprint 4</a:t>
             </a:r>
           </a:p>
           <a:p>
             <a:pPr>
               <a:spcAft>
-                <a:spcPts val="1200"/>
+                <a:spcPts val="1000"/>
               </a:spcAft>
             </a:pPr>
             <a:r>
-              <a:rPr sz="1000">
+              <a:rPr sz="900">
                 <a:solidFill>
                   <a:srgbClr val="66BB6A"/>
                 </a:solidFill>
@@ -5591,32 +5591,32 @@
               <a:t>● </a:t>
             </a:r>
             <a:r>
-              <a:rPr b="1" sz="1500">
+              <a:rPr b="1" sz="1400">
                 <a:solidFill>
                   <a:srgbClr val="F3E9E2"/>
                 </a:solidFill>
                 <a:latin typeface="Calibri"/>
               </a:rPr>
-              <a:t>Tareas en Jira: </a:t>
-            </a:r>
-            <a:r>
-              <a:rPr sz="1500">
+              <a:t>HU-17: </a:t>
+            </a:r>
+            <a:r>
+              <a:rPr sz="1400">
                 <a:solidFill>
                   <a:srgbClr val="BCAAA4"/>
                 </a:solidFill>
                 <a:latin typeface="Calibri"/>
               </a:rPr>
-              <a:t>[COMPLETAR]</a:t>
+              <a:t>Confirmación de pagos y saldo · 3 pts · Sprint 4</a:t>
             </a:r>
           </a:p>
           <a:p>
             <a:pPr>
               <a:spcAft>
-                <a:spcPts val="1200"/>
+                <a:spcPts val="1000"/>
               </a:spcAft>
             </a:pPr>
             <a:r>
-              <a:rPr sz="1000">
+              <a:rPr sz="900">
                 <a:solidFill>
                   <a:srgbClr val="66BB6A"/>
                 </a:solidFill>
@@ -5625,90 +5625,22 @@
               <a:t>● </a:t>
             </a:r>
             <a:r>
-              <a:rPr b="1" sz="1500">
+              <a:rPr b="1" sz="1400">
                 <a:solidFill>
                   <a:srgbClr val="F3E9E2"/>
                 </a:solidFill>
                 <a:latin typeface="Calibri"/>
               </a:rPr>
-              <a:t>Aporte a documentación: </a:t>
-            </a:r>
-            <a:r>
-              <a:rPr sz="1500">
+              <a:t>Aporte realizado hasta hoy: </a:t>
+            </a:r>
+            <a:r>
+              <a:rPr sz="1400">
                 <a:solidFill>
                   <a:srgbClr val="BCAAA4"/>
                 </a:solidFill>
                 <a:latin typeface="Calibri"/>
               </a:rPr>
-              <a:t>[COMPLETAR]</a:t>
-            </a:r>
-          </a:p>
-          <a:p>
-            <a:pPr>
-              <a:spcAft>
-                <a:spcPts val="1200"/>
-              </a:spcAft>
-            </a:pPr>
-            <a:r>
-              <a:rPr sz="1000">
-                <a:solidFill>
-                  <a:srgbClr val="66BB6A"/>
-                </a:solidFill>
-                <a:latin typeface="Calibri"/>
-              </a:rPr>
-              <a:t>● </a:t>
-            </a:r>
-            <a:r>
-              <a:rPr b="1" sz="1500">
-                <a:solidFill>
-                  <a:srgbClr val="F3E9E2"/>
-                </a:solidFill>
-                <a:latin typeface="Calibri"/>
-              </a:rPr>
-              <a:t>Aporte a pruebas: </a:t>
-            </a:r>
-            <a:r>
-              <a:rPr sz="1500">
-                <a:solidFill>
-                  <a:srgbClr val="BCAAA4"/>
-                </a:solidFill>
-                <a:latin typeface="Calibri"/>
-              </a:rPr>
-              <a:t>[COMPLETAR]</a:t>
-            </a:r>
-          </a:p>
-          <a:p>
-            <a:pPr>
-              <a:spcAft>
-                <a:spcPts val="1200"/>
-              </a:spcAft>
-            </a:pPr>
-            <a:r>
-              <a:rPr sz="1000">
-                <a:solidFill>
-                  <a:srgbClr val="66BB6A"/>
-                </a:solidFill>
-                <a:latin typeface="Calibri"/>
-              </a:rPr>
-              <a:t>● </a:t>
-            </a:r>
-            <a:r>
-              <a:rPr b="1" sz="1500">
-                <a:solidFill>
-                  <a:srgbClr val="F3E9E2"/>
-                </a:solidFill>
-                <a:latin typeface="Calibri"/>
-              </a:rPr>
-              <a:t>Dificultades y aprendizajes: </a:t>
-            </a:r>
-            <a:r>
-              <a:rPr sz="1500">
-                <a:solidFill>
-                  <a:srgbClr val="BCAAA4"/>
-                </a:solidFill>
-                <a:latin typeface="Calibri"/>
-              </a:rPr>
-              <a:t>[COMPLETAR]</a:t>
+              <a:t>[COMPLETAR con Jira/Git]</a:t>
             </a:r>
           </a:p>
         </p:txBody>
@@ -6356,7 +6288,7 @@
                 </a:solidFill>
                 <a:latin typeface="Calibri"/>
               </a:rPr>
-              <a:t>Contribuciones</a:t>
+              <a:t>Compromisos y contribuciones</a:t>
             </a:r>
           </a:p>
         </p:txBody>
@@ -6385,11 +6317,11 @@
           <a:p>
             <a:pPr>
               <a:spcAft>
-                <a:spcPts val="1200"/>
+                <a:spcPts val="1000"/>
               </a:spcAft>
             </a:pPr>
             <a:r>
-              <a:rPr sz="1000">
+              <a:rPr sz="900">
                 <a:solidFill>
                   <a:srgbClr val="66BB6A"/>
                 </a:solidFill>
@@ -6398,32 +6330,32 @@
               <a:t>● </a:t>
             </a:r>
             <a:r>
-              <a:rPr b="1" sz="1500">
+              <a:rPr b="1" sz="1400">
                 <a:solidFill>
                   <a:srgbClr val="F3E9E2"/>
                 </a:solidFill>
                 <a:latin typeface="Calibri"/>
               </a:rPr>
-              <a:t>Trabajo realizado: </a:t>
-            </a:r>
-            <a:r>
-              <a:rPr sz="1500">
+              <a:t>HU-08: </a:t>
+            </a:r>
+            <a:r>
+              <a:rPr sz="1400">
                 <a:solidFill>
                   <a:srgbClr val="BCAAA4"/>
                 </a:solidFill>
                 <a:latin typeface="Calibri"/>
               </a:rPr>
-              <a:t>[COMPLETAR]</a:t>
+              <a:t>Actualización y baja de productos · 3 pts · Sprint 3</a:t>
             </a:r>
           </a:p>
           <a:p>
             <a:pPr>
               <a:spcAft>
-                <a:spcPts val="1200"/>
+                <a:spcPts val="1000"/>
               </a:spcAft>
             </a:pPr>
             <a:r>
-              <a:rPr sz="1000">
+              <a:rPr sz="900">
                 <a:solidFill>
                   <a:srgbClr val="66BB6A"/>
                 </a:solidFill>
@@ -6432,32 +6364,32 @@
               <a:t>● </a:t>
             </a:r>
             <a:r>
-              <a:rPr b="1" sz="1500">
+              <a:rPr b="1" sz="1400">
                 <a:solidFill>
                   <a:srgbClr val="F3E9E2"/>
                 </a:solidFill>
                 <a:latin typeface="Calibri"/>
               </a:rPr>
-              <a:t>Commits, ramas y pull requests: </a:t>
-            </a:r>
-            <a:r>
-              <a:rPr sz="1500">
+              <a:t>HU-14: </a:t>
+            </a:r>
+            <a:r>
+              <a:rPr sz="1400">
                 <a:solidFill>
                   <a:srgbClr val="BCAAA4"/>
                 </a:solidFill>
                 <a:latin typeface="Calibri"/>
               </a:rPr>
-              <a:t>[COMPLETAR]</a:t>
+              <a:t>Adjuntar documentos · 5 pts · Sprint 3</a:t>
             </a:r>
           </a:p>
           <a:p>
             <a:pPr>
               <a:spcAft>
-                <a:spcPts val="1200"/>
+                <a:spcPts val="1000"/>
               </a:spcAft>
             </a:pPr>
             <a:r>
-              <a:rPr sz="1000">
+              <a:rPr sz="900">
                 <a:solidFill>
                   <a:srgbClr val="66BB6A"/>
                 </a:solidFill>
@@ -6466,32 +6398,32 @@
               <a:t>● </a:t>
             </a:r>
             <a:r>
-              <a:rPr b="1" sz="1500">
+              <a:rPr b="1" sz="1400">
                 <a:solidFill>
                   <a:srgbClr val="F3E9E2"/>
                 </a:solidFill>
                 <a:latin typeface="Calibri"/>
               </a:rPr>
-              <a:t>Tareas en Jira: </a:t>
-            </a:r>
-            <a:r>
-              <a:rPr sz="1500">
+              <a:t>HU-15: </a:t>
+            </a:r>
+            <a:r>
+              <a:rPr sz="1400">
                 <a:solidFill>
                   <a:srgbClr val="BCAAA4"/>
                 </a:solidFill>
                 <a:latin typeface="Calibri"/>
               </a:rPr>
-              <a:t>[COMPLETAR]</a:t>
+              <a:t>Verificación de documentos obligatorios · 3 pts · Sprint 3</a:t>
             </a:r>
           </a:p>
           <a:p>
             <a:pPr>
               <a:spcAft>
-                <a:spcPts val="1200"/>
+                <a:spcPts val="1000"/>
               </a:spcAft>
             </a:pPr>
             <a:r>
-              <a:rPr sz="1000">
+              <a:rPr sz="900">
                 <a:solidFill>
                   <a:srgbClr val="66BB6A"/>
                 </a:solidFill>
@@ -6500,90 +6432,22 @@
               <a:t>● </a:t>
             </a:r>
             <a:r>
-              <a:rPr b="1" sz="1500">
+              <a:rPr b="1" sz="1400">
                 <a:solidFill>
                   <a:srgbClr val="F3E9E2"/>
                 </a:solidFill>
                 <a:latin typeface="Calibri"/>
               </a:rPr>
-              <a:t>Aporte a documentación: </a:t>
-            </a:r>
-            <a:r>
-              <a:rPr sz="1500">
+              <a:t>Aporte realizado hasta hoy: </a:t>
+            </a:r>
+            <a:r>
+              <a:rPr sz="1400">
                 <a:solidFill>
                   <a:srgbClr val="BCAAA4"/>
                 </a:solidFill>
                 <a:latin typeface="Calibri"/>
               </a:rPr>
-              <a:t>[COMPLETAR]</a:t>
-            </a:r>
-          </a:p>
-          <a:p>
-            <a:pPr>
-              <a:spcAft>
-                <a:spcPts val="1200"/>
-              </a:spcAft>
-            </a:pPr>
-            <a:r>
-              <a:rPr sz="1000">
-                <a:solidFill>
-                  <a:srgbClr val="66BB6A"/>
-                </a:solidFill>
-                <a:latin typeface="Calibri"/>
-              </a:rPr>
-              <a:t>● </a:t>
-            </a:r>
-            <a:r>
-              <a:rPr b="1" sz="1500">
-                <a:solidFill>
-                  <a:srgbClr val="F3E9E2"/>
-                </a:solidFill>
-                <a:latin typeface="Calibri"/>
-              </a:rPr>
-              <a:t>Aporte a pruebas: </a:t>
-            </a:r>
-            <a:r>
-              <a:rPr sz="1500">
-                <a:solidFill>
-                  <a:srgbClr val="BCAAA4"/>
-                </a:solidFill>
-                <a:latin typeface="Calibri"/>
-              </a:rPr>
-              <a:t>[COMPLETAR]</a:t>
-            </a:r>
-          </a:p>
-          <a:p>
-            <a:pPr>
-              <a:spcAft>
-                <a:spcPts val="1200"/>
-              </a:spcAft>
-            </a:pPr>
-            <a:r>
-              <a:rPr sz="1000">
-                <a:solidFill>
-                  <a:srgbClr val="66BB6A"/>
-                </a:solidFill>
-                <a:latin typeface="Calibri"/>
-              </a:rPr>
-              <a:t>● </a:t>
-            </a:r>
-            <a:r>
-              <a:rPr b="1" sz="1500">
-                <a:solidFill>
-                  <a:srgbClr val="F3E9E2"/>
-                </a:solidFill>
-                <a:latin typeface="Calibri"/>
-              </a:rPr>
-              <a:t>Dificultades y aprendizajes: </a:t>
-            </a:r>
-            <a:r>
-              <a:rPr sz="1500">
-                <a:solidFill>
-                  <a:srgbClr val="BCAAA4"/>
-                </a:solidFill>
-                <a:latin typeface="Calibri"/>
-              </a:rPr>
-              <a:t>[COMPLETAR]</a:t>
+              <a:t>[COMPLETAR con Jira/Git]</a:t>
             </a:r>
           </a:p>
         </p:txBody>
@@ -7231,7 +7095,7 @@
                 </a:solidFill>
                 <a:latin typeface="Calibri"/>
               </a:rPr>
-              <a:t>Contribuciones</a:t>
+              <a:t>Compromisos y contribuciones</a:t>
             </a:r>
           </a:p>
         </p:txBody>
@@ -7260,11 +7124,11 @@
           <a:p>
             <a:pPr>
               <a:spcAft>
-                <a:spcPts val="1200"/>
+                <a:spcPts val="1000"/>
               </a:spcAft>
             </a:pPr>
             <a:r>
-              <a:rPr sz="1000">
+              <a:rPr sz="900">
                 <a:solidFill>
                   <a:srgbClr val="66BB6A"/>
                 </a:solidFill>
@@ -7273,32 +7137,32 @@
               <a:t>● </a:t>
             </a:r>
             <a:r>
-              <a:rPr b="1" sz="1500">
+              <a:rPr b="1" sz="1400">
                 <a:solidFill>
                   <a:srgbClr val="F3E9E2"/>
                 </a:solidFill>
                 <a:latin typeface="Calibri"/>
               </a:rPr>
-              <a:t>Trabajo realizado: </a:t>
-            </a:r>
-            <a:r>
-              <a:rPr sz="1500">
+              <a:t>HU-09: </a:t>
+            </a:r>
+            <a:r>
+              <a:rPr sz="1400">
                 <a:solidFill>
                   <a:srgbClr val="BCAAA4"/>
                 </a:solidFill>
                 <a:latin typeface="Calibri"/>
               </a:rPr>
-              <a:t>[COMPLETAR]</a:t>
+              <a:t>Alerta de stock mínimo · 3 pts · Sprint 3</a:t>
             </a:r>
           </a:p>
           <a:p>
             <a:pPr>
               <a:spcAft>
-                <a:spcPts val="1200"/>
+                <a:spcPts val="1000"/>
               </a:spcAft>
             </a:pPr>
             <a:r>
-              <a:rPr sz="1000">
+              <a:rPr sz="900">
                 <a:solidFill>
                   <a:srgbClr val="66BB6A"/>
                 </a:solidFill>
@@ -7307,32 +7171,32 @@
               <a:t>● </a:t>
             </a:r>
             <a:r>
-              <a:rPr b="1" sz="1500">
+              <a:rPr b="1" sz="1400">
                 <a:solidFill>
                   <a:srgbClr val="F3E9E2"/>
                 </a:solidFill>
                 <a:latin typeface="Calibri"/>
               </a:rPr>
-              <a:t>Commits, ramas y pull requests: </a:t>
-            </a:r>
-            <a:r>
-              <a:rPr sz="1500">
+              <a:t>HU-11: </a:t>
+            </a:r>
+            <a:r>
+              <a:rPr sz="1400">
                 <a:solidFill>
                   <a:srgbClr val="BCAAA4"/>
                 </a:solidFill>
                 <a:latin typeface="Calibri"/>
               </a:rPr>
-              <a:t>[COMPLETAR]</a:t>
+              <a:t>Crear exportación · 8 pts · Sprint 3</a:t>
             </a:r>
           </a:p>
           <a:p>
             <a:pPr>
               <a:spcAft>
-                <a:spcPts val="1200"/>
+                <a:spcPts val="1000"/>
               </a:spcAft>
             </a:pPr>
             <a:r>
-              <a:rPr sz="1000">
+              <a:rPr sz="900">
                 <a:solidFill>
                   <a:srgbClr val="66BB6A"/>
                 </a:solidFill>
@@ -7341,32 +7205,32 @@
               <a:t>● </a:t>
             </a:r>
             <a:r>
-              <a:rPr b="1" sz="1500">
+              <a:rPr b="1" sz="1400">
                 <a:solidFill>
                   <a:srgbClr val="F3E9E2"/>
                 </a:solidFill>
                 <a:latin typeface="Calibri"/>
               </a:rPr>
-              <a:t>Tareas en Jira: </a:t>
-            </a:r>
-            <a:r>
-              <a:rPr sz="1500">
+              <a:t>HU-12: </a:t>
+            </a:r>
+            <a:r>
+              <a:rPr sz="1400">
                 <a:solidFill>
                   <a:srgbClr val="BCAAA4"/>
                 </a:solidFill>
                 <a:latin typeface="Calibri"/>
               </a:rPr>
-              <a:t>[COMPLETAR]</a:t>
+              <a:t>Seguimiento del estado de la exportación · 5 pts · Sprint 3</a:t>
             </a:r>
           </a:p>
           <a:p>
             <a:pPr>
               <a:spcAft>
-                <a:spcPts val="1200"/>
+                <a:spcPts val="1000"/>
               </a:spcAft>
             </a:pPr>
             <a:r>
-              <a:rPr sz="1000">
+              <a:rPr sz="900">
                 <a:solidFill>
                   <a:srgbClr val="66BB6A"/>
                 </a:solidFill>
@@ -7375,32 +7239,32 @@
               <a:t>● </a:t>
             </a:r>
             <a:r>
-              <a:rPr b="1" sz="1500">
+              <a:rPr b="1" sz="1400">
                 <a:solidFill>
                   <a:srgbClr val="F3E9E2"/>
                 </a:solidFill>
                 <a:latin typeface="Calibri"/>
               </a:rPr>
-              <a:t>Aporte a documentación: </a:t>
-            </a:r>
-            <a:r>
-              <a:rPr sz="1500">
+              <a:t>HU-10: </a:t>
+            </a:r>
+            <a:r>
+              <a:rPr sz="1400">
                 <a:solidFill>
                   <a:srgbClr val="BCAAA4"/>
                 </a:solidFill>
                 <a:latin typeface="Calibri"/>
               </a:rPr>
-              <a:t>[COMPLETAR]</a:t>
+              <a:t>Historial de movimientos · 3 pts · Sprint 4</a:t>
             </a:r>
           </a:p>
           <a:p>
             <a:pPr>
               <a:spcAft>
-                <a:spcPts val="1200"/>
+                <a:spcPts val="1000"/>
               </a:spcAft>
             </a:pPr>
             <a:r>
-              <a:rPr sz="1000">
+              <a:rPr sz="900">
                 <a:solidFill>
                   <a:srgbClr val="66BB6A"/>
                 </a:solidFill>
@@ -7409,32 +7273,32 @@
               <a:t>● </a:t>
             </a:r>
             <a:r>
-              <a:rPr b="1" sz="1500">
+              <a:rPr b="1" sz="1400">
                 <a:solidFill>
                   <a:srgbClr val="F3E9E2"/>
                 </a:solidFill>
                 <a:latin typeface="Calibri"/>
               </a:rPr>
-              <a:t>Aporte a pruebas: </a:t>
-            </a:r>
-            <a:r>
-              <a:rPr sz="1500">
+              <a:t>HU-13: </a:t>
+            </a:r>
+            <a:r>
+              <a:rPr sz="1400">
                 <a:solidFill>
                   <a:srgbClr val="BCAAA4"/>
                 </a:solidFill>
                 <a:latin typeface="Calibri"/>
               </a:rPr>
-              <a:t>[COMPLETAR]</a:t>
+              <a:t>Listado de exportaciones · 3 pts · Sprint 4</a:t>
             </a:r>
           </a:p>
           <a:p>
             <a:pPr>
               <a:spcAft>
-                <a:spcPts val="1200"/>
+                <a:spcPts val="1000"/>
               </a:spcAft>
             </a:pPr>
             <a:r>
-              <a:rPr sz="1000">
+              <a:rPr sz="900">
                 <a:solidFill>
                   <a:srgbClr val="66BB6A"/>
                 </a:solidFill>
@@ -7443,22 +7307,22 @@
               <a:t>● </a:t>
             </a:r>
             <a:r>
-              <a:rPr b="1" sz="1500">
+              <a:rPr b="1" sz="1400">
                 <a:solidFill>
                   <a:srgbClr val="F3E9E2"/>
                 </a:solidFill>
                 <a:latin typeface="Calibri"/>
               </a:rPr>
-              <a:t>Dificultades y aprendizajes: </a:t>
-            </a:r>
-            <a:r>
-              <a:rPr sz="1500">
+              <a:t>Aporte realizado hasta hoy: </a:t>
+            </a:r>
+            <a:r>
+              <a:rPr sz="1400">
                 <a:solidFill>
                   <a:srgbClr val="BCAAA4"/>
                 </a:solidFill>
                 <a:latin typeface="Calibri"/>
               </a:rPr>
-              <a:t>[COMPLETAR]</a:t>
+              <a:t>[COMPLETAR con Jira/Git]</a:t>
             </a:r>
           </a:p>
         </p:txBody>
@@ -8106,7 +7970,7 @@
                 </a:solidFill>
                 <a:latin typeface="Calibri"/>
               </a:rPr>
-              <a:t>Contribuciones</a:t>
+              <a:t>Compromisos y contribuciones</a:t>
             </a:r>
           </a:p>
         </p:txBody>
@@ -8135,11 +7999,11 @@
           <a:p>
             <a:pPr>
               <a:spcAft>
-                <a:spcPts val="1200"/>
+                <a:spcPts val="1000"/>
               </a:spcAft>
             </a:pPr>
             <a:r>
-              <a:rPr sz="1000">
+              <a:rPr sz="900">
                 <a:solidFill>
                   <a:srgbClr val="66BB6A"/>
                 </a:solidFill>
@@ -8148,32 +8012,32 @@
               <a:t>● </a:t>
             </a:r>
             <a:r>
-              <a:rPr b="1" sz="1500">
+              <a:rPr b="1" sz="1400">
                 <a:solidFill>
                   <a:srgbClr val="F3E9E2"/>
                 </a:solidFill>
                 <a:latin typeface="Calibri"/>
               </a:rPr>
-              <a:t>Trabajo realizado: </a:t>
-            </a:r>
-            <a:r>
-              <a:rPr sz="1500">
+              <a:t>HU-18: </a:t>
+            </a:r>
+            <a:r>
+              <a:rPr sz="1400">
                 <a:solidFill>
                   <a:srgbClr val="BCAAA4"/>
                 </a:solidFill>
                 <a:latin typeface="Calibri"/>
               </a:rPr>
-              <a:t>[COMPLETAR]</a:t>
+              <a:t>Reporte de exportaciones por fechas · 5 pts · Sprint 4</a:t>
             </a:r>
           </a:p>
           <a:p>
             <a:pPr>
               <a:spcAft>
-                <a:spcPts val="1200"/>
+                <a:spcPts val="1000"/>
               </a:spcAft>
             </a:pPr>
             <a:r>
-              <a:rPr sz="1000">
+              <a:rPr sz="900">
                 <a:solidFill>
                   <a:srgbClr val="66BB6A"/>
                 </a:solidFill>
@@ -8182,32 +8046,32 @@
               <a:t>● </a:t>
             </a:r>
             <a:r>
-              <a:rPr b="1" sz="1500">
+              <a:rPr b="1" sz="1400">
                 <a:solidFill>
                   <a:srgbClr val="F3E9E2"/>
                 </a:solidFill>
                 <a:latin typeface="Calibri"/>
               </a:rPr>
-              <a:t>Commits, ramas y pull requests: </a:t>
-            </a:r>
-            <a:r>
-              <a:rPr sz="1500">
+              <a:t>HU-19: </a:t>
+            </a:r>
+            <a:r>
+              <a:rPr sz="1400">
                 <a:solidFill>
                   <a:srgbClr val="BCAAA4"/>
                 </a:solidFill>
                 <a:latin typeface="Calibri"/>
               </a:rPr>
-              <a:t>[COMPLETAR]</a:t>
+              <a:t>Exportar reportes a PDF y Excel · 3 pts · Sprint 4</a:t>
             </a:r>
           </a:p>
           <a:p>
             <a:pPr>
               <a:spcAft>
-                <a:spcPts val="1200"/>
+                <a:spcPts val="1000"/>
               </a:spcAft>
             </a:pPr>
             <a:r>
-              <a:rPr sz="1000">
+              <a:rPr sz="900">
                 <a:solidFill>
                   <a:srgbClr val="66BB6A"/>
                 </a:solidFill>
@@ -8216,124 +8080,22 @@
               <a:t>● </a:t>
             </a:r>
             <a:r>
-              <a:rPr b="1" sz="1500">
+              <a:rPr b="1" sz="1400">
                 <a:solidFill>
                   <a:srgbClr val="F3E9E2"/>
                 </a:solidFill>
                 <a:latin typeface="Calibri"/>
               </a:rPr>
-              <a:t>Tareas en Jira: </a:t>
-            </a:r>
-            <a:r>
-              <a:rPr sz="1500">
+              <a:t>Aporte realizado hasta hoy: </a:t>
+            </a:r>
+            <a:r>
+              <a:rPr sz="1400">
                 <a:solidFill>
                   <a:srgbClr val="BCAAA4"/>
                 </a:solidFill>
                 <a:latin typeface="Calibri"/>
               </a:rPr>
-              <a:t>[COMPLETAR]</a:t>
-            </a:r>
-          </a:p>
-          <a:p>
-            <a:pPr>
-              <a:spcAft>
-                <a:spcPts val="1200"/>
-              </a:spcAft>
-            </a:pPr>
-            <a:r>
-              <a:rPr sz="1000">
-                <a:solidFill>
-                  <a:srgbClr val="66BB6A"/>
-                </a:solidFill>
-                <a:latin typeface="Calibri"/>
-              </a:rPr>
-              <a:t>● </a:t>
-            </a:r>
-            <a:r>
-              <a:rPr b="1" sz="1500">
-                <a:solidFill>
-                  <a:srgbClr val="F3E9E2"/>
-                </a:solidFill>
-                <a:latin typeface="Calibri"/>
-              </a:rPr>
-              <a:t>Aporte a documentación: </a:t>
-            </a:r>
-            <a:r>
-              <a:rPr sz="1500">
-                <a:solidFill>
-                  <a:srgbClr val="BCAAA4"/>
-                </a:solidFill>
-                <a:latin typeface="Calibri"/>
-              </a:rPr>
-              <a:t>[COMPLETAR]</a:t>
-            </a:r>
-          </a:p>
-          <a:p>
-            <a:pPr>
-              <a:spcAft>
-                <a:spcPts val="1200"/>
-              </a:spcAft>
-            </a:pPr>
-            <a:r>
-              <a:rPr sz="1000">
-                <a:solidFill>
-                  <a:srgbClr val="66BB6A"/>
-                </a:solidFill>
-                <a:latin typeface="Calibri"/>
-              </a:rPr>
-              <a:t>● </a:t>
-            </a:r>
-            <a:r>
-              <a:rPr b="1" sz="1500">
-                <a:solidFill>
-                  <a:srgbClr val="F3E9E2"/>
-                </a:solidFill>
-                <a:latin typeface="Calibri"/>
-              </a:rPr>
-              <a:t>Aporte a pruebas: </a:t>
-            </a:r>
-            <a:r>
-              <a:rPr sz="1500">
-                <a:solidFill>
-                  <a:srgbClr val="BCAAA4"/>
-                </a:solidFill>
-                <a:latin typeface="Calibri"/>
-              </a:rPr>
-              <a:t>[COMPLETAR]</a:t>
-            </a:r>
-          </a:p>
-          <a:p>
-            <a:pPr>
-              <a:spcAft>
-                <a:spcPts val="1200"/>
-              </a:spcAft>
-            </a:pPr>
-            <a:r>
-              <a:rPr sz="1000">
-                <a:solidFill>
-                  <a:srgbClr val="66BB6A"/>
-                </a:solidFill>
-                <a:latin typeface="Calibri"/>
-              </a:rPr>
-              <a:t>● </a:t>
-            </a:r>
-            <a:r>
-              <a:rPr b="1" sz="1500">
-                <a:solidFill>
-                  <a:srgbClr val="F3E9E2"/>
-                </a:solidFill>
-                <a:latin typeface="Calibri"/>
-              </a:rPr>
-              <a:t>Dificultades y aprendizajes: </a:t>
-            </a:r>
-            <a:r>
-              <a:rPr sz="1500">
-                <a:solidFill>
-                  <a:srgbClr val="BCAAA4"/>
-                </a:solidFill>
-                <a:latin typeface="Calibri"/>
-              </a:rPr>
-              <a:t>[COMPLETAR]</a:t>
+              <a:t>[COMPLETAR con Jira/Git]</a:t>
             </a:r>
           </a:p>
         </p:txBody>
@@ -19053,7 +18815,7 @@
                 </a:solidFill>
                 <a:latin typeface="Calibri"/>
               </a:rPr>
-              <a:t>Contribuciones</a:t>
+              <a:t>Compromisos y contribuciones</a:t>
             </a:r>
           </a:p>
         </p:txBody>
@@ -19082,11 +18844,11 @@
           <a:p>
             <a:pPr>
               <a:spcAft>
-                <a:spcPts val="1200"/>
+                <a:spcPts val="1000"/>
               </a:spcAft>
             </a:pPr>
             <a:r>
-              <a:rPr sz="1000">
+              <a:rPr sz="900">
                 <a:solidFill>
                   <a:srgbClr val="66BB6A"/>
                 </a:solidFill>
@@ -19095,32 +18857,32 @@
               <a:t>● </a:t>
             </a:r>
             <a:r>
-              <a:rPr b="1" sz="1500">
+              <a:rPr b="1" sz="1400">
                 <a:solidFill>
                   <a:srgbClr val="F3E9E2"/>
                 </a:solidFill>
                 <a:latin typeface="Calibri"/>
               </a:rPr>
-              <a:t>Trabajo realizado: </a:t>
-            </a:r>
-            <a:r>
-              <a:rPr sz="1500">
+              <a:t>HU-05: </a:t>
+            </a:r>
+            <a:r>
+              <a:rPr sz="1400">
                 <a:solidFill>
                   <a:srgbClr val="BCAAA4"/>
                 </a:solidFill>
                 <a:latin typeface="Calibri"/>
               </a:rPr>
-              <a:t>[COMPLETAR]</a:t>
+              <a:t>Gestión de usuarios y roles · 5 pts · Sprint 3</a:t>
             </a:r>
           </a:p>
           <a:p>
             <a:pPr>
               <a:spcAft>
-                <a:spcPts val="1200"/>
+                <a:spcPts val="1000"/>
               </a:spcAft>
             </a:pPr>
             <a:r>
-              <a:rPr sz="1000">
+              <a:rPr sz="900">
                 <a:solidFill>
                   <a:srgbClr val="66BB6A"/>
                 </a:solidFill>
@@ -19129,32 +18891,32 @@
               <a:t>● </a:t>
             </a:r>
             <a:r>
-              <a:rPr b="1" sz="1500">
+              <a:rPr b="1" sz="1400">
                 <a:solidFill>
                   <a:srgbClr val="F3E9E2"/>
                 </a:solidFill>
                 <a:latin typeface="Calibri"/>
               </a:rPr>
-              <a:t>Commits, ramas y pull requests: </a:t>
-            </a:r>
-            <a:r>
-              <a:rPr sz="1500">
+              <a:t>HU-06: </a:t>
+            </a:r>
+            <a:r>
+              <a:rPr sz="1400">
                 <a:solidFill>
                   <a:srgbClr val="BCAAA4"/>
                 </a:solidFill>
                 <a:latin typeface="Calibri"/>
               </a:rPr>
-              <a:t>[COMPLETAR]</a:t>
+              <a:t>Control de acceso por rol · 3 pts · Sprint 3</a:t>
             </a:r>
           </a:p>
           <a:p>
             <a:pPr>
               <a:spcAft>
-                <a:spcPts val="1200"/>
+                <a:spcPts val="1000"/>
               </a:spcAft>
             </a:pPr>
             <a:r>
-              <a:rPr sz="1000">
+              <a:rPr sz="900">
                 <a:solidFill>
                   <a:srgbClr val="66BB6A"/>
                 </a:solidFill>
@@ -19163,32 +18925,32 @@
               <a:t>● </a:t>
             </a:r>
             <a:r>
-              <a:rPr b="1" sz="1500">
+              <a:rPr b="1" sz="1400">
                 <a:solidFill>
                   <a:srgbClr val="F3E9E2"/>
                 </a:solidFill>
                 <a:latin typeface="Calibri"/>
               </a:rPr>
-              <a:t>Tareas en Jira: </a:t>
-            </a:r>
-            <a:r>
-              <a:rPr sz="1500">
+              <a:t>HU-20: </a:t>
+            </a:r>
+            <a:r>
+              <a:rPr sz="1400">
                 <a:solidFill>
                   <a:srgbClr val="BCAAA4"/>
                 </a:solidFill>
                 <a:latin typeface="Calibri"/>
               </a:rPr>
-              <a:t>[COMPLETAR]</a:t>
+              <a:t>KPIs del dashboard · 5 pts · Sprint 4</a:t>
             </a:r>
           </a:p>
           <a:p>
             <a:pPr>
               <a:spcAft>
-                <a:spcPts val="1200"/>
+                <a:spcPts val="1000"/>
               </a:spcAft>
             </a:pPr>
             <a:r>
-              <a:rPr sz="1000">
+              <a:rPr sz="900">
                 <a:solidFill>
                   <a:srgbClr val="66BB6A"/>
                 </a:solidFill>
@@ -19197,32 +18959,32 @@
               <a:t>● </a:t>
             </a:r>
             <a:r>
-              <a:rPr b="1" sz="1500">
+              <a:rPr b="1" sz="1400">
                 <a:solidFill>
                   <a:srgbClr val="F3E9E2"/>
                 </a:solidFill>
                 <a:latin typeface="Calibri"/>
               </a:rPr>
-              <a:t>Aporte a documentación: </a:t>
-            </a:r>
-            <a:r>
-              <a:rPr sz="1500">
+              <a:t>HU-21: </a:t>
+            </a:r>
+            <a:r>
+              <a:rPr sz="1400">
                 <a:solidFill>
                   <a:srgbClr val="BCAAA4"/>
                 </a:solidFill>
                 <a:latin typeface="Calibri"/>
               </a:rPr>
-              <a:t>[COMPLETAR]</a:t>
+              <a:t>Gráficas y últimas exportaciones · 5 pts · Sprint 4</a:t>
             </a:r>
           </a:p>
           <a:p>
             <a:pPr>
               <a:spcAft>
-                <a:spcPts val="1200"/>
+                <a:spcPts val="1000"/>
               </a:spcAft>
             </a:pPr>
             <a:r>
-              <a:rPr sz="1000">
+              <a:rPr sz="900">
                 <a:solidFill>
                   <a:srgbClr val="66BB6A"/>
                 </a:solidFill>
@@ -19231,56 +18993,22 @@
               <a:t>● </a:t>
             </a:r>
             <a:r>
-              <a:rPr b="1" sz="1500">
+              <a:rPr b="1" sz="1400">
                 <a:solidFill>
                   <a:srgbClr val="F3E9E2"/>
                 </a:solidFill>
                 <a:latin typeface="Calibri"/>
               </a:rPr>
-              <a:t>Aporte a pruebas: </a:t>
-            </a:r>
-            <a:r>
-              <a:rPr sz="1500">
+              <a:t>Aporte realizado hasta hoy: </a:t>
+            </a:r>
+            <a:r>
+              <a:rPr sz="1400">
                 <a:solidFill>
                   <a:srgbClr val="BCAAA4"/>
                 </a:solidFill>
                 <a:latin typeface="Calibri"/>
               </a:rPr>
-              <a:t>[COMPLETAR]</a:t>
-            </a:r>
-          </a:p>
-          <a:p>
-            <a:pPr>
-              <a:spcAft>
-                <a:spcPts val="1200"/>
-              </a:spcAft>
-            </a:pPr>
-            <a:r>
-              <a:rPr sz="1000">
-                <a:solidFill>
-                  <a:srgbClr val="66BB6A"/>
-                </a:solidFill>
-                <a:latin typeface="Calibri"/>
-              </a:rPr>
-              <a:t>● </a:t>
-            </a:r>
-            <a:r>
-              <a:rPr b="1" sz="1500">
-                <a:solidFill>
-                  <a:srgbClr val="F3E9E2"/>
-                </a:solidFill>
-                <a:latin typeface="Calibri"/>
-              </a:rPr>
-              <a:t>Dificultades y aprendizajes: </a:t>
-            </a:r>
-            <a:r>
-              <a:rPr sz="1500">
-                <a:solidFill>
-                  <a:srgbClr val="BCAAA4"/>
-                </a:solidFill>
-                <a:latin typeface="Calibri"/>
-              </a:rPr>
-              <a:t>[COMPLETAR]</a:t>
+              <a:t>[COMPLETAR con Jira/Git]</a:t>
             </a:r>
           </a:p>
         </p:txBody>

</xml_diff>

<commit_message>
Presentación: quitar marcadores pendientes de las diapositivas 6 y 8
Responsables del Sprint 1 como propuesta y estado de las pruebas como
pendiente de ejecución.
</commit_message>
<xml_diff>
--- a/docs/sprint2/CoffeeExport_Manager_Sprint2.pptx
+++ b/docs/sprint2/CoffeeExport_Manager_Sprint2.pptx
@@ -651,7 +651,7 @@
           <a:lstStyle/>
           <a:p>
             <a:r>
-              <a:t>Resumen del estado. LISTO: Sprint 1 con HU-01 a HU-04 (autenticación, clientes, productos e inventario) y los mockups de Login, Dashboard, Nueva Exportación y Reportes. EN PROGRESO: documentación de calidad del Sprint 2 (requerimientos, UML, backlog, modelo de datos) y ejecución del plan de pruebas. SIGUE: implementar Exportaciones y Documentación, completar Usuarios, y luego Pagos, Reportes y Dashboard. Aclarar que el estado del Sprint 1 debe validarse contra el código y Jira [COMPLETAR]. Tiempo: 1 minuto.</a:t>
+              <a:t>Resumen del estado. LISTO: Sprint 1 con HU-01 a HU-04 (autenticación, clientes, productos e inventario) y los mockups de Login, Dashboard, Nueva Exportación y Reportes. EN PROGRESO: documentación de calidad del Sprint 2 (requerimientos, UML, backlog, modelo de datos) y ejecución del plan de pruebas. SIGUE: implementar Exportaciones y Documentación, completar Usuarios, y luego Pagos, Reportes y Dashboard. Aclarar que el estado del Sprint 1 debe validarse contra el código y Jira. Tiempo: 1 minuto.</a:t>
             </a:r>
           </a:p>
         </p:txBody>
@@ -931,7 +931,7 @@
           <a:lstStyle/>
           <a:p>
             <a:r>
-              <a:t>Los cuatro ítems del Sprint 1: HU-01 Autenticación, HU-02 Clientes, HU-03 Productos y HU-04 Inventario. Los responsables mostrados son una propuesta tentativa, marcada [COMPLETAR], pues deben confirmarse con Jira y con el historial de Git; el repositorio estaba vacío al preparar esta presentación. Cada integrante ampliará su aporte en las diapositivas individuales. Tiempo: 45 segundos.</a:t>
+              <a:t>Los cuatro ítems del Sprint 1: HU-01 Autenticación, HU-02 Clientes, HU-03 Productos y HU-04 Inventario. Los responsables mostrados son una propuesta que debe confirmarse con Jira y con el historial de Git; el código del Sprint 1 no estaba en el repositorio al preparar esta presentación. Cada integrante ampliará su aporte en las diapositivas individuales. Tiempo: 45 segundos.</a:t>
             </a:r>
           </a:p>
         </p:txBody>
@@ -1071,7 +1071,7 @@
           <a:lstStyle/>
           <a:p>
             <a:r>
-              <a:t>El plan tiene 44 casos de prueba usando la plantilla de la materia. Mezcla pruebas unitarias sobre servicios y repositorios, de integración sobre controladores REST con MySQL, del sistema sobre los flujos de pantalla, y de seguridad (login fallido, BCrypt, acceso sin rol, inyección SQL básica). 35 casos cubren HU-01 a HU-04, que corresponden al Sprint 1. 9 casos son de módulos aún no implementados y quedan como pendientes. Importante: aún no se han registrado resultados de ejecución; las columnas resultado obtenido, pasa/no y fecha están como [COMPLETAR]. No presentamos porcentajes de éxito porque no se han ejecutado. Los nombres de clases y métodos están marcados [VERIFICAR] hasta contrastarlos con el repositorio. Tiempo: 1 minuto.</a:t>
+              <a:t>El plan tiene 44 casos de prueba usando la plantilla de la materia. Mezcla pruebas unitarias sobre servicios y repositorios, de integración sobre controladores REST con MySQL, del sistema sobre los flujos de pantalla, y de seguridad (login fallido, BCrypt, acceso sin rol, inyección SQL básica). 35 casos cubren HU-01 a HU-04, que corresponden al Sprint 1. 9 casos son de módulos aún no implementados y quedan como pendientes. Importante: aún no se han registrado resultados de ejecución; las columnas resultado obtenido, pasa/no y fecha del plan están pendientes de diligenciar. No presentamos porcentajes de éxito porque no se han ejecutado. Los nombres de clases y métodos están marcados [VERIFICAR] hasta contrastarlos con el repositorio. Tiempo: 1 minuto.</a:t>
             </a:r>
           </a:p>
         </p:txBody>
@@ -9702,7 +9702,7 @@
                           </a:solidFill>
                           <a:latin typeface="Calibri"/>
                         </a:rPr>
-                        <a:t>[COMPLETAR] (propuesta: Brayan Guerrero)</a:t>
+                        <a:t>Brayan Guerrero (propuesta)</a:t>
                       </a:r>
                     </a:p>
                   </a:txBody>
@@ -9814,7 +9814,7 @@
                           </a:solidFill>
                           <a:latin typeface="Calibri"/>
                         </a:rPr>
-                        <a:t>[COMPLETAR] (propuesta: Juan Jurado)</a:t>
+                        <a:t>Juan Jurado (propuesta)</a:t>
                       </a:r>
                     </a:p>
                   </a:txBody>
@@ -9926,7 +9926,7 @@
                           </a:solidFill>
                           <a:latin typeface="Calibri"/>
                         </a:rPr>
-                        <a:t>[COMPLETAR] (propuesta: Nicoll López)</a:t>
+                        <a:t>Nicoll López (propuesta)</a:t>
                       </a:r>
                     </a:p>
                   </a:txBody>
@@ -10038,7 +10038,7 @@
                           </a:solidFill>
                           <a:latin typeface="Calibri"/>
                         </a:rPr>
-                        <a:t>[COMPLETAR] (propuesta: Alexander Rodríguez)</a:t>
+                        <a:t>Alexander Rodríguez (propuesta)</a:t>
                       </a:r>
                     </a:p>
                   </a:txBody>
@@ -10105,7 +10105,7 @@
                 </a:solidFill>
                 <a:latin typeface="Calibri"/>
               </a:rPr>
-              <a:t>Propuesta tentativa de responsables: no proviene de Git ni de Jira. El equipo debe completarla con los datos reales.</a:t>
+              <a:t>Responsables propuestos según el plan por módulo; no provienen de Git ni de Jira y deben confirmarse.</a:t>
             </a:r>
           </a:p>
         </p:txBody>
@@ -13263,7 +13263,7 @@
                 </a:solidFill>
                 <a:latin typeface="Calibri"/>
               </a:rPr>
-              <a:t>0 · resultados [COMPLETAR]</a:t>
+              <a:t>0 · pendiente de ejecución</a:t>
             </a:r>
           </a:p>
           <a:p>

</xml_diff>